<commit_message>
docs(presentation): sync English defence kit with v3 results
</commit_message>
<xml_diff>
--- a/docs/presentation/en/1c-mcp-rag-search-slides-en.pptx
+++ b/docs/presentation/en/1c-mcp-rag-search-slides-en.pptx
@@ -770,7 +770,7 @@
           <a:lstStyle/>
           <a:p>
             <a:r>
-              <a:t>Read the table top to bottom: vector 0.339, pearson 0.337, hybrid 0.301, rerank 0.117. Paired comparison: +0.037 with a confidence interval that crosses zero and p = 0.154, so I did not flip the default. The 2x2 ablation then explains why the leader moved: with symbolic chunking hybrid wins, with procedural chunking vector wins, and the export effect at symbolic chunking is inside run noise. One cell is missing because the old dump no longer exists, so additivity is assumed.</a:t>
+              <a:t>Read the table top to bottom: vector 0.339, pearson 0.337, hybrid 0.301, rerank 0.117. The paired test on v2 gives +0.037 with an interval that crosses zero (p = 0.154). I then ran an independent 100-query v3 hold-out that never touched tuning: on 71 code queries over three runs vector is 0.205 and hybrid 0.183, delta +0.023, p = 0.275, again not significant. So the default stays hybrid and ADR 0009 remains proposed. The 2x2 ablation explains why the leader moved: symbolic chunking favours hybrid, procedural chunking favours vector, and the export effect is inside run noise.</a:t>
             </a:r>
           </a:p>
         </p:txBody>
@@ -5578,7 +5578,7 @@
                 </a:solidFill>
                 <a:latin typeface="Calibri"/>
               </a:rPr>
-              <a:t>Paired test: vector vs hybrid</a:t>
+              <a:t>Validation: v2 and independent v3 hold-out</a:t>
             </a:r>
           </a:p>
         </p:txBody>
@@ -5592,7 +5592,7 @@
         <p:spPr>
           <a:xfrm>
             <a:off x="6035040" y="3273552"/>
-            <a:ext cx="5669280" cy="777240"/>
+            <a:ext cx="5669280" cy="822960"/>
           </a:xfrm>
           <a:prstGeom prst="rect">
             <a:avLst/>
@@ -5607,19 +5607,20 @@
           <a:p>
             <a:pPr algn="l">
               <a:lnSpc>
-                <a:spcPct val="105000"/>
-              </a:lnSpc>
-            </a:pPr>
-            <a:r>
-              <a:rPr sz="1080" b="0">
+                <a:spcPct val="100000"/>
+              </a:lnSpc>
+            </a:pPr>
+            <a:r>
+              <a:rPr sz="960" b="0">
                 <a:solidFill>
                   <a:srgbClr val="1F2A33"/>
                 </a:solidFill>
                 <a:latin typeface="Calibri"/>
               </a:rPr>
-              <a:t>Δ nDCG@10 = +0.037
-bootstrap 95% CI [-0.015; +0.086], p = 0.154
-Not significant: default unchanged, ADR 0009 stays proposed.</a:t>
+              <a:t>v2: Δ +0.037, CI [-0.015; +0.086], p = 0.154
+v3 (71 code queries, 3 runs): vector 0.205 ± 0.014 / hybrid 0.183 ± 0.005
+v3: Δ +0.023, CI [-0.019; +0.061], p = 0.275 — not significant
+Both not significant: default hybrid unchanged, ADR 0009 stays proposed.</a:t>
             </a:r>
           </a:p>
         </p:txBody>
@@ -6827,7 +6828,7 @@
                 </a:solidFill>
                 <a:latin typeface="Calibri"/>
               </a:rPr>
-              <a:t>•  The routing gain is within noise; a new hold-out set is needed</a:t>
+              <a:t>•  v3 hold-out: router 58/100; quoted-name lexical cases fall back to hybrid</a:t>
             </a:r>
           </a:p>
         </p:txBody>

</xml_diff>